<commit_message>
Presentation revisions: Tatay spelling, Ash, scope + conclusion slides, Batbat videos
- Correct the farmer's honorific spelling from Tatae to Tatay across
  every file (site, docs, SVGs, speaker PDFs, and the PPTX).
- Add Ash to the team: she presents the claim-worth-checking callout
  and a new conclusion recap slide before the thank-you; new Ash.pdf
  speaker script.
- Add a scope slide (in scope vs. out of scope) after the problems
  slide.
- Rework the investors slide so it reads as recommendations for Tatay
  and Muravah, not stage directions.
- Batbat slide now holds one photo and two videos (autoplay, muted,
  looping) with clear upload instructions in images/README.md.
- Widen chart-slide spacing so plots no longer crowd each other, and
  add the first real field photo (pest infestation).
</commit_message>
<xml_diff>
--- a/Bicol-Cacao-Pitch.pptx
+++ b/Bicol-Cacao-Pitch.pptx
@@ -737,7 +737,7 @@
                 </a:solidFill>
                 <a:latin typeface="Arial"/>
               </a:rPr>
-              <a:t>Tatae's cacao yield (kg/yr)</a:t>
+              <a:t>Tatay's cacao yield (kg/yr)</a:t>
             </a:r>
           </a:p>
         </c:rich>
@@ -2555,7 +2555,7 @@
           <a:p>
             <a:r>
               <a:rPr lang="en-US" dirty="0"/>
-              <a:t>PRESENTER: Nancy. Open energetically — you're setting the tone for the whole room. Say who we are and why we're credible: this isn't invented, it's built from real interviews with a cacao NGO (Muravah Foundation / Mayon Gold), a smallholder farmer (Tatae, Batbat), a processing facility, and site visits Aug 26-28 across Bicol. State the thesis out loud: 'every solution we propose already works somewhere in Bicol — our job is showing how to bring it to cacao.' Keep this slide under 30 seconds; the room should feel like real people did real fieldwork, not that this is a hypothetical exercise.</a:t>
+              <a:t>PRESENTER: Nancy. Open energetically — you're setting the tone for the whole room. Say who we are and why we're credible: this isn't invented, it's built from real interviews with a cacao NGO (Muravah Foundation / Mayon Gold), a smallholder farmer (Tatay, Batbat), a processing facility, and site visits Aug 26-28 across Bicol. State the thesis out loud: 'every solution we propose already works somewhere in Bicol — our job is showing how to bring it to cacao.' Keep this slide under 30 seconds; the room should feel like real people did real fieldwork, not that this is a hypothetical exercise.</a:t>
             </a:r>
             <a:endParaRPr lang="en-US" dirty="0"/>
           </a:p>
@@ -2819,7 +2819,7 @@
           <a:p>
             <a:r>
               <a:rPr lang="en-US" dirty="0"/>
-              <a:t>PRESENTER: Nancy. This is the emotional low point of the deck, right before we pivot to solutions — take your time here. Pest and disease pressure, not typhoon, not transport, not land tenure, is what's driving Tatae's cacao yield to nearly zero. Because cacao flowers year-round, the pressure never lets up — there's no off-season where the farm gets a break. Name the disease agent if asked: Phytophthora, almost certainly Phytophthora palmivora, the classic cacao black pod disease; also birds, and a viral disease affecting pod production. Make this about Tatae as a person, not an abstract statistic, before we move into what we're proposing to do about it.</a:t>
+              <a:t>PRESENTER: Nancy. This is the emotional low point of the deck, right before we pivot to solutions — take your time here. Pest and disease pressure, not typhoon, not transport, not land tenure, is what's driving Tatay's cacao yield to nearly zero. Because cacao flowers year-round, the pressure never lets up — there's no off-season where the farm gets a break. Name the disease agent if asked: Phytophthora, almost certainly Phytophthora palmivora, the classic cacao black pod disease; also birds, and a viral disease affecting pod production. Make this about Tatay as a person, not an abstract statistic, before we move into what we're proposing to do about it.</a:t>
             </a:r>
             <a:endParaRPr lang="en-US" dirty="0"/>
           </a:p>
@@ -2907,7 +2907,7 @@
           <a:p>
             <a:r>
               <a:rPr lang="en-US" dirty="0"/>
-              <a:t>PRESENTER: Chow only — this is the one slide that's entirely yours; no one else needs to study this in depth. Explain what you built and why: rather than eyeballing a drip-irrigation pilot for Tatae's farm, you built a working set of field tools — a drip-pressure planner sized to his real 2.5-hectare / 120-meter layout, a water-system schematic (gravity vs. pump modes), and an interactive schematic editor — so any water-resilience pilot for Tatae is calculated from his actual numbers, not guessed. Point the room at the GitHub repo (github.com/Abdullah-Nasir-Chowdhury/cacao-bicol-field-tools), which also holds the full field-notes reference and the interactive chart dashboard this deck draws its numbers from. Keep the framing tight: this is the concrete, checkable, technical contribution — invite people to actually open it later rather than trying to demo it live if time is short.</a:t>
+              <a:t>PRESENTER: Chow only — this is the one slide that's entirely yours; no one else needs to study this in depth. Explain what you built and why: rather than eyeballing a drip-irrigation pilot for Tatay's farm, you built a working set of field tools — a drip-pressure planner sized to his real 2.5-hectare / 120-meter layout, a water-system schematic (gravity vs. pump modes), and an interactive schematic editor — so any water-resilience pilot for Tatay is calculated from his actual numbers, not guessed. Point the room at the GitHub repo (github.com/Abdullah-Nasir-Chowdhury/cacao-bicol-field-tools), which also holds the full field-notes reference and the interactive chart dashboard this deck draws its numbers from. Keep the framing tight: this is the concrete, checkable, technical contribution — invite people to actually open it later rather than trying to demo it live if time is short.</a:t>
             </a:r>
             <a:endParaRPr lang="en-US" dirty="0"/>
           </a:p>
@@ -2995,7 +2995,7 @@
           <a:p>
             <a:r>
               <a:rPr lang="en-US" dirty="0"/>
-              <a:t>PRESENTER: Keisuke. This is the payoff slide for 'adapt, don't invent.' Of 12 candidate pest/disease solutions we brainstormed, only 6 survived independent fact-checking against the actual interview data — say that filtering process out loud, it's a credibility point. They group into three approaches: monitoring &amp; routine discipline (3 — a cacao-adapted 15-day treatment calendar borrowed from the taro project's proven schedule; a field-officer symptom-logging checklist; a centralized compliance-and-bio-input ledger), biological &amp; cultural control (2 — an herbal foliar/pod spray adapted from the rice/dairy farm's practice; an amino-acid/molasses bio-concoction on the taro project's 15-day cycle), and post-harvest handling (1 — rolling phytosanitation rounds every 7–14 days). Land the recommendation clearly: for Tatae specifically, start with the 15-day calendar plus the herbal spray — cheapest to start, no new equipment, and it fits his limited labor capacity given his health constraints. The ledger and the amino-acid spray follow once the calendar habit is established.</a:t>
+              <a:t>PRESENTER: Keisuke. This is the payoff slide for 'adapt, don't invent.' Of 12 candidate pest/disease solutions we brainstormed, only 6 survived independent fact-checking against the actual interview data — say that filtering process out loud, it's a credibility point. They group into three approaches: monitoring &amp; routine discipline (3 — a cacao-adapted 15-day treatment calendar borrowed from the taro project's proven schedule; a field-officer symptom-logging checklist; a centralized compliance-and-bio-input ledger), biological &amp; cultural control (2 — an herbal foliar/pod spray adapted from the rice/dairy farm's practice; an amino-acid/molasses bio-concoction on the taro project's 15-day cycle), and post-harvest handling (1 — rolling phytosanitation rounds every 7–14 days). Land the recommendation clearly: for Tatay specifically, start with the 15-day calendar plus the herbal spray — cheapest to start, no new equipment, and it fits his limited labor capacity given his health constraints. The ledger and the amino-acid spray follow once the calendar habit is established.</a:t>
             </a:r>
             <a:endParaRPr lang="en-US" dirty="0"/>
           </a:p>
@@ -3083,7 +3083,7 @@
           <a:p>
             <a:r>
               <a:rPr lang="en-US" dirty="0"/>
-              <a:t>PRESENTER: Masa. This slide was flagged as especially important — don't rush it. Four points, and you can frame all of them as your 'the numbers back this up' close: (1) everything proposed is organic-only, low-cost, human-in-the-loop, no synthetic inputs or AI/robotics — that's not a technology choice, it's literally what Muravah and Tatae told us they need. (2) It's the single largest lever in our whole dataset: resolving pest/disease pressure is a ~4x yield recovery for Tatae, 0 kg to a potential 2,000 kg/year. (3) It fixes two problems at once — stabilizing farm-level supply also stabilizes the processing facility, which told us it's 'sometimes out of supply for cacao' because of these same upstream losses. (4) Nothing here is invented from scratch — it's the rice/dairy farm's spray practice and the taro project's schedule discipline, adapted with honestly-stated caveats to cacao's arboreal, year-round biology.</a:t>
+              <a:t>PRESENTER: Masa. This slide was flagged as especially important — don't rush it. Four points, and you can frame all of them as your 'the numbers back this up' close: (1) everything proposed is organic-only, low-cost, human-in-the-loop, no synthetic inputs or AI/robotics — that's not a technology choice, it's literally what Muravah and Tatay told us they need. (2) It's the single largest lever in our whole dataset: resolving pest/disease pressure is a ~4x yield recovery for Tatay, 0 kg to a potential 2,000 kg/year. (3) It fixes two problems at once — stabilizing farm-level supply also stabilizes the processing facility, which told us it's 'sometimes out of supply for cacao' because of these same upstream losses. (4) Nothing here is invented from scratch — it's the rice/dairy farm's spray practice and the taro project's schedule discipline, adapted with honestly-stated caveats to cacao's arboreal, year-round biology.</a:t>
             </a:r>
             <a:endParaRPr lang="en-US" dirty="0"/>
           </a:p>
@@ -3171,7 +3171,7 @@
           <a:p>
             <a:r>
               <a:rPr lang="en-US" dirty="0"/>
-              <a:t>PRESENTER: Keisuke. Open with Tatae's own quote: he told us directly that 'a pilot study and investors would be needed.' Then give three concrete ways to help him find them: (1) point to the regional funding precedent — the Zambales solar farm secured ₱10 million for a comparable-scale agri-infrastructure pilot, which is concrete proof that regional agri-tech investment appetite exists and gives us a benchmark to pitch against. (2) Package the pilot inside Muravah's existing 500–1,000-farmer production-cycle study rather than pitching it as one lone farmer's ask — investors get an established NGO's track record and scale behind it. (3) Lead with the organic price-premium ROI story: frame the ask as bridge capital toward organic/export certification, where a projected 4x yield recovery plus a price premium is a real return case, not just a request for aid. This is your tradeoffs lane — feel free to speak to the organic-vs-export-vs-income tension if asked.</a:t>
+              <a:t>PRESENTER: Keisuke. Open with Tatay's own quote: he told us directly that 'a pilot study and investors would be needed.' Then give three concrete ways to help him find them: (1) point to the regional funding precedent — the Zambales solar farm secured ₱10 million for a comparable-scale agri-infrastructure pilot, which is concrete proof that regional agri-tech investment appetite exists and gives us a benchmark to pitch against. (2) Package the pilot inside Muravah's existing 500–1,000-farmer production-cycle study rather than pitching it as one lone farmer's ask — investors get an established NGO's track record and scale behind it. (3) Lead with the organic price-premium ROI story: frame the ask as bridge capital toward organic/export certification, where a projected 4x yield recovery plus a price premium is a real return case, not just a request for aid. This is your tradeoffs lane — feel free to speak to the organic-vs-export-vs-income tension if asked.</a:t>
             </a:r>
             <a:endParaRPr lang="en-US" dirty="0"/>
           </a:p>
@@ -3699,7 +3699,7 @@
           <a:p>
             <a:r>
               <a:rPr lang="en-US" dirty="0"/>
-              <a:t>PRESENTER: Ria. This is an image-only slide by design — let the photos carry it, keep your narration short and personal. We visited Tatae's 2.5-hectare cacao farm in the Batbat area on August 26. He's a solo operator (his children work in the cities), 100% organic, and dealing with real health problems that limit how much labor-intensive work he can physically do himself. Set up the emotional stakes here in one or two sentences — the numbers come on the next slide.</a:t>
+              <a:t>PRESENTER: Ria. This is an image-only slide by design — let the photos carry it, keep your narration short and personal. We visited Tatay's 2.5-hectare cacao farm in the Batbat area on August 26. He's a solo operator (his children work in the cities), 100% organic, and dealing with real health problems that limit how much labor-intensive work he can physically do himself. Set up the emotional stakes here in one or two sentences — the numbers come on the next slide.</a:t>
             </a:r>
             <a:endParaRPr lang="en-US" dirty="0"/>
           </a:p>
@@ -3787,7 +3787,7 @@
           <a:p>
             <a:r>
               <a:rPr lang="en-US" dirty="0"/>
-              <a:t>PRESENTER: Masa. Three charts, one farm. (1) Post-harvest loss by cause: 60% from careless handling, pests/disease reported as an 80–100% range (chart shows the midpoint, 90%, — say the real range out loud, don't just point at the number), typhoon near 100% in a bad year. (2) Tatae's own cacao yield: historically 500 kg/year, but currently near 0 kg due to pest/disease — his estimated potential if pests were resolved is 2,000 kg/year. Say this slowly: that's a 4x recovery, and it's the single largest lever in our entire dataset. (3) Farmer monthly income benchmarks Muravah cited: a ₱2,000 low reference, a ₱5,000 example farmer, and ₱10,000 named as a 'low' ceiling — context for how thin the margins are region-wide, not just for Tatae.</a:t>
+              <a:t>PRESENTER: Masa. Three charts, one farm. (1) Post-harvest loss by cause: 60% from careless handling, pests/disease reported as an 80–100% range (chart shows the midpoint, 90%, — say the real range out loud, don't just point at the number), typhoon near 100% in a bad year. (2) Tatay's own cacao yield: historically 500 kg/year, but currently near 0 kg due to pest/disease — his estimated potential if pests were resolved is 2,000 kg/year. Say this slowly: that's a 4x recovery, and it's the single largest lever in our entire dataset. (3) Farmer monthly income benchmarks Muravah cited: a ₱2,000 low reference, a ₱5,000 example farmer, and ₱10,000 named as a 'low' ceiling — context for how thin the margins are region-wide, not just for Tatay.</a:t>
             </a:r>
             <a:endParaRPr lang="en-US" dirty="0"/>
           </a:p>
@@ -3875,7 +3875,7 @@
           <a:p>
             <a:r>
               <a:rPr lang="en-US" dirty="0"/>
-              <a:t>PRESENTER: Ria. Image-only slide again — narrate briefly. August 27 we visited Tatae Aldavis's rice/dairy farm (a completely different farmer from Tatae in Batbat — same honorific, different person, worth clarifying if anyone's confused) which is thriving, government-supported, and runs an accredited farm school. They control pests with herbal sprays and ducks grazing on snails, though a chemical fallback exists. We also visited a bamboo farm (no problems reported except typhoon) and stingless-bee honey producers (honey, bee, and propolis — propolis being the most valuable, used medicinally). The throughline: these are proof that low-tech, organic pest control already works elsewhere in Bicol.</a:t>
+              <a:t>PRESENTER: Ria. Image-only slide again — narrate briefly. August 27 we visited Tatay Aldavis's rice/dairy farm (a completely different farmer from Tatay in Batbat — same honorific, different person, worth clarifying if anyone's confused) which is thriving, government-supported, and runs an accredited farm school. They control pests with herbal sprays and ducks grazing on snails, though a chemical fallback exists. We also visited a bamboo farm (no problems reported except typhoon) and stingless-bee honey producers (honey, bee, and propolis — propolis being the most valuable, used medicinally). The throughline: these are proof that low-tech, organic pest control already works elsewhere in Bicol.</a:t>
             </a:r>
             <a:endParaRPr lang="en-US" dirty="0"/>
           </a:p>
@@ -5253,7 +5253,7 @@
                 <a:ea typeface="Cambria" pitchFamily="34" charset="-122"/>
                 <a:cs typeface="Cambria" pitchFamily="34" charset="-120"/>
               </a:rPr>
-              <a:t>What we found at Tatae's farm</a:t>
+              <a:t>What we found at Tatay's farm</a:t>
             </a:r>
             <a:endParaRPr lang="en-US" sz="2900" dirty="0"/>
           </a:p>
@@ -5295,7 +5295,7 @@
                 <a:ea typeface="Calibri" pitchFamily="34" charset="-122"/>
                 <a:cs typeface="Calibri" pitchFamily="34" charset="-120"/>
               </a:rPr>
-              <a:t>Pest and disease pressure — not typhoon, not transport, not land tenure — is what's driving Tatae's cacao yield to nearly zero. Continuous, year-round flowering means the pressure never lets up.</a:t>
+              <a:t>Pest and disease pressure — not typhoon, not transport, not land tenure — is what's driving Tatay's cacao yield to nearly zero. Continuous, year-round flowering means the pressure never lets up.</a:t>
             </a:r>
             <a:endParaRPr lang="en-US" sz="1350" dirty="0"/>
           </a:p>
@@ -5400,7 +5400,7 @@
                 <a:ea typeface="Calibri" pitchFamily="34" charset="-122"/>
                 <a:cs typeface="Calibri" pitchFamily="34" charset="-120"/>
               </a:rPr>
-              <a:t>[ image placeholder — pest infestation at Tatae's farm ]</a:t>
+              <a:t>[ image placeholder — pest infestation at Tatay's farm ]</a:t>
             </a:r>
             <a:endParaRPr lang="en-US" sz="1100" dirty="0"/>
           </a:p>
@@ -5840,7 +5840,7 @@
                 <a:ea typeface="Calibri" pitchFamily="34" charset="-122"/>
                 <a:cs typeface="Calibri" pitchFamily="34" charset="-120"/>
               </a:rPr>
-              <a:t>Rather than eyeball a drip-irrigation pilot for Tatae's farm, we built a working set of field tools: a drip-pressure planner sized to his real 2.5 ha / 120 m layout, a water-system schematic, and an interactive editor — so any water-resilience pilot is calculated, not guessed.</a:t>
+              <a:t>Rather than eyeball a drip-irrigation pilot for Tatay's farm, we built a working set of field tools: a drip-pressure planner sized to his real 2.5 ha / 120 m layout, a water-system schematic, and an interactive editor — so any water-resilience pilot is calculated, not guessed.</a:t>
             </a:r>
             <a:endParaRPr lang="en-US" sz="1400" dirty="0"/>
           </a:p>
@@ -6925,7 +6925,7 @@
                 <a:ea typeface="Calibri" pitchFamily="34" charset="-122"/>
                 <a:cs typeface="Calibri" pitchFamily="34" charset="-120"/>
               </a:rPr>
-              <a:t>Recommended for Tatae first: </a:t>
+              <a:t>Recommended for Tatay first: </a:t>
             </a:r>
             <a:pPr indent="0" marL="0">
               <a:lnSpc>
@@ -7231,7 +7231,7 @@
                 <a:ea typeface="Calibri" pitchFamily="34" charset="-122"/>
                 <a:cs typeface="Calibri" pitchFamily="34" charset="-120"/>
               </a:rPr>
-              <a:t>Organic-only, low-cost, human-in-the-loop — no synthetic inputs, no AI/robotics — because that's Muravah and Tatae's explicit requirement, not what's technologically fashionable.</a:t>
+              <a:t>Organic-only, low-cost, human-in-the-loop — no synthetic inputs, no AI/robotics — because that's Muravah and Tatay's explicit requirement, not what's technologically fashionable.</a:t>
             </a:r>
             <a:endParaRPr lang="en-US" sz="1250" dirty="0"/>
           </a:p>
@@ -7371,7 +7371,7 @@
                 <a:ea typeface="Calibri" pitchFamily="34" charset="-122"/>
                 <a:cs typeface="Calibri" pitchFamily="34" charset="-120"/>
               </a:rPr>
-              <a:t>If pest/disease pressure comes down, Tatae's own numbers point to a ~4× recovery: 0 kg to a potential 2,000 kg/year.</a:t>
+              <a:t>If pest/disease pressure comes down, Tatay's own numbers point to a ~4× recovery: 0 kg to a potential 2,000 kg/year.</a:t>
             </a:r>
             <a:endParaRPr lang="en-US" sz="1250" dirty="0"/>
           </a:p>
@@ -7803,7 +7803,7 @@
                 <a:ea typeface="Cambria" pitchFamily="34" charset="-122"/>
                 <a:cs typeface="Cambria" pitchFamily="34" charset="-120"/>
               </a:rPr>
-              <a:t>Tatae's own words: “a pilot study and investors would be needed”</a:t>
+              <a:t>Tatay's own words: “a pilot study and investors would be needed”</a:t>
             </a:r>
             <a:endParaRPr lang="en-US" sz="2200" dirty="0"/>
           </a:p>
@@ -7842,7 +7842,7 @@
                 <a:ea typeface="Calibri" pitchFamily="34" charset="-122"/>
                 <a:cs typeface="Calibri" pitchFamily="34" charset="-120"/>
               </a:rPr>
-              <a:t>Three concrete ways to help Tatae find investors:</a:t>
+              <a:t>Three concrete ways to help Tatay find investors:</a:t>
             </a:r>
             <a:endParaRPr lang="en-US" sz="1300" dirty="0"/>
           </a:p>
@@ -8122,7 +8122,7 @@
                 <a:ea typeface="Calibri" pitchFamily="34" charset="-122"/>
                 <a:cs typeface="Calibri" pitchFamily="34" charset="-120"/>
               </a:rPr>
-              <a:t>Fold Tatae's pilot into Muravah's 500–1,000-farmer production-cycle study already underway — investors get an established NGO's track record and scale behind one farmer's ask, not a lone request.</a:t>
+              <a:t>Fold Tatay's pilot into Muravah's 500–1,000-farmer production-cycle study already underway — investors get an established NGO's track record and scale behind one farmer's ask, not a lone request.</a:t>
             </a:r>
             <a:endParaRPr lang="en-US" sz="1250" dirty="0"/>
           </a:p>
@@ -8550,7 +8550,7 @@
                 <a:ea typeface="Calibri" pitchFamily="34" charset="-122"/>
                 <a:cs typeface="Calibri" pitchFamily="34" charset="-120"/>
               </a:rPr>
-              <a:t>Nancy · Masa · Keisuke · Ria · Chow</a:t>
+              <a:t>Nancy · Masa · Keisuke · Ria · Ash · Chow</a:t>
             </a:r>
             <a:endParaRPr lang="en-US" sz="1100" dirty="0"/>
           </a:p>
@@ -10349,7 +10349,7 @@
                 <a:ea typeface="Cambria" pitchFamily="34" charset="-122"/>
                 <a:cs typeface="Cambria" pitchFamily="34" charset="-120"/>
               </a:rPr>
-              <a:t>Tatae's Farm, Batbat</a:t>
+              <a:t>Tatay's Farm, Batbat</a:t>
             </a:r>
             <a:endParaRPr lang="en-US" sz="3000" dirty="0"/>
           </a:p>
@@ -10391,7 +10391,7 @@
                 <a:ea typeface="Calibri" pitchFamily="34" charset="-122"/>
                 <a:cs typeface="Calibri" pitchFamily="34" charset="-120"/>
               </a:rPr>
-              <a:t>We visited Tatae's 2.5-hectare cacao farm in the Batbat area to see the pest and disease crisis firsthand.</a:t>
+              <a:t>We visited Tatay's 2.5-hectare cacao farm in the Batbat area to see the pest and disease crisis firsthand.</a:t>
             </a:r>
             <a:endParaRPr lang="en-US" sz="1400" dirty="0"/>
           </a:p>
@@ -10496,7 +10496,7 @@
                 <a:ea typeface="Calibri" pitchFamily="34" charset="-122"/>
                 <a:cs typeface="Calibri" pitchFamily="34" charset="-120"/>
               </a:rPr>
-              <a:t>[ image placeholder — arriving at Tatae's farm, Batbat ]</a:t>
+              <a:t>[ image placeholder — arriving at Tatay's farm, Batbat ]</a:t>
             </a:r>
             <a:endParaRPr lang="en-US" sz="1100" dirty="0"/>
           </a:p>
@@ -10601,7 +10601,7 @@
                 <a:ea typeface="Calibri" pitchFamily="34" charset="-122"/>
                 <a:cs typeface="Calibri" pitchFamily="34" charset="-120"/>
               </a:rPr>
-              <a:t>[ image placeholder — Tatae's cacao trees / farm overview ]</a:t>
+              <a:t>[ image placeholder — Tatay's cacao trees / farm overview ]</a:t>
             </a:r>
             <a:endParaRPr lang="en-US" sz="1100" dirty="0"/>
           </a:p>
@@ -10711,7 +10711,7 @@
                 <a:ea typeface="Calibri" pitchFamily="34" charset="-122"/>
                 <a:cs typeface="Calibri" pitchFamily="34" charset="-120"/>
               </a:rPr>
-              <a:t>FIELD VISIT · AUGUST 26 — TATAE'S FARM, BATBAT</a:t>
+              <a:t>FIELD VISIT · AUGUST 26 — TATAY'S FARM, BATBAT</a:t>
             </a:r>
             <a:endParaRPr lang="en-US" sz="1100" dirty="0"/>
           </a:p>
@@ -10837,7 +10837,7 @@
                 <a:ea typeface="Calibri" pitchFamily="34" charset="-122"/>
                 <a:cs typeface="Calibri" pitchFamily="34" charset="-120"/>
               </a:rPr>
-              <a:t>Pests/disease shown at the midpoint of the reported 80–100% range. Source: Muravah Foundation interview + Tatae's own account.</a:t>
+              <a:t>Pests/disease shown at the midpoint of the reported 80–100% range. Source: Muravah Foundation interview + Tatay's own account.</a:t>
             </a:r>
             <a:endParaRPr lang="en-US" sz="1050" dirty="0"/>
           </a:p>
@@ -11028,7 +11028,7 @@
                 <a:ea typeface="Calibri" pitchFamily="34" charset="-122"/>
                 <a:cs typeface="Calibri" pitchFamily="34" charset="-120"/>
               </a:rPr>
-              <a:t>We visited Tatae Aldavis's thriving rice/dairy farm and farm school, a bamboo farm, and stingless-bee honey producers to see what's already working in Bicol agriculture.</a:t>
+              <a:t>We visited Tatay Aldavis's thriving rice/dairy farm and farm school, a bamboo farm, and stingless-bee honey producers to see what's already working in Bicol agriculture.</a:t>
             </a:r>
             <a:endParaRPr lang="en-US" sz="1400" dirty="0"/>
           </a:p>

</xml_diff>

<commit_message>
Correct idea attribution: the pilot and solutions are the team's own conclusions
Tatay described the problems and constraints; the pilot-study/investor
plan and every proposed solution came from the group's own
investigations. Reworded the investors slide, FIELD-NOTES,
SPEAKER-NOTES (including Keisuke's Japanese translation), the
regenerated speaker PDFs, and the PPTX accordingly.
</commit_message>
<xml_diff>
--- a/Bicol-Cacao-Pitch.pptx
+++ b/Bicol-Cacao-Pitch.pptx
@@ -3171,7 +3171,7 @@
           <a:p>
             <a:r>
               <a:rPr lang="en-US" dirty="0"/>
-              <a:t>PRESENTER: Keisuke. Open with Tatay's own quote: he told us directly that 'a pilot study and investors would be needed.' Then give three concrete ways to help him find them: (1) point to the regional funding precedent — the Zambales solar farm secured ₱10 million for a comparable-scale agri-infrastructure pilot, which is concrete proof that regional agri-tech investment appetite exists and gives us a benchmark to pitch against. (2) Package the pilot inside Muravah's existing 500–1,000-farmer production-cycle study rather than pitching it as one lone farmer's ask — investors get an established NGO's track record and scale behind it. (3) Lead with the organic price-premium ROI story: frame the ask as bridge capital toward organic/export certification, where a projected 4x yield recovery plus a price premium is a real return case, not just a request for aid. This is your tradeoffs lane — feel free to speak to the organic-vs-export-vs-income tension if asked.</a:t>
+              <a:t>PRESENTER: Keisuke. Open by owning the conclusion: our investigation found that a funded pilot study is what stands between Tatay's farm and recovery. Careful with attribution: Tatay described the problems and constraints, but the pilot/investor plan and every proposed solution came from our group's own investigations, not from him. Then give three concrete ways to fund it: (1) point to the regional funding precedent — the Zambales solar farm secured ₱10 million for a comparable-scale agri-infrastructure pilot, which is concrete proof that regional agri-tech investment appetite exists and gives us a benchmark to pitch against. (2) Package the pilot inside Muravah's existing 500–1,000-farmer production-cycle study rather than pitching it as one lone farmer's ask — investors get an established NGO's track record and scale behind it. (3) Lead with the organic price-premium ROI story: frame the ask as bridge capital toward organic/export certification, where a projected 4x yield recovery plus a price premium is a real return case, not just a request for aid. This is your tradeoffs lane — feel free to speak to the organic-vs-export-vs-income tension if asked.</a:t>
             </a:r>
             <a:endParaRPr lang="en-US" dirty="0"/>
           </a:p>
@@ -7803,7 +7803,7 @@
                 <a:ea typeface="Cambria" pitchFamily="34" charset="-122"/>
                 <a:cs typeface="Cambria" pitchFamily="34" charset="-120"/>
               </a:rPr>
-              <a:t>Tatay's own words: “a pilot study and investors would be needed”</a:t>
+              <a:t>Our conclusion: a funded pilot study is the missing piece</a:t>
             </a:r>
             <a:endParaRPr lang="en-US" sz="2200" dirty="0"/>
           </a:p>
@@ -7842,7 +7842,7 @@
                 <a:ea typeface="Calibri" pitchFamily="34" charset="-122"/>
                 <a:cs typeface="Calibri" pitchFamily="34" charset="-120"/>
               </a:rPr>
-              <a:t>Three concrete ways to help Tatay find investors:</a:t>
+              <a:t>Tatay described the problems; this plan is our group's own. Three ways to fund it:</a:t>
             </a:r>
             <a:endParaRPr lang="en-US" sz="1300" dirty="0"/>
           </a:p>

</xml_diff>